<commit_message>
feat: Add multi-jurisdiction PDF generation for CTR/SAR/LVTR/FIR
- Add pdf_gen.py utility using reportlab for proper PDF output
- CTR/SAR/FIR downloads now support ?format=rbi|rma (India/Bhutan)
- LVTR model, API routes, and seed data (RMA Rule 14, Nu. 100,000)
- ComplianceCTRPage and ComplianceLVTRPage added as standalone pages
- PoliceFIRPage: fix missing Upload import (caused blank page crash)
- FIR download: fix offense_date/offense_description attribute names
- render.yaml: fix start command (app.main:app → main:app)
- netlify.toml: force=true on API proxy redirect, correct Render URL
- PPT: add Investigation Copilot and Regulatory Document slides

Co-Authored-By: Claude Sonnet 4.6 <noreply@anthropic.com>
</commit_message>
<xml_diff>
--- a/FinsurgeENRIMS_MultiRegulator_RMA.pptx
+++ b/FinsurgeENRIMS_MultiRegulator_RMA.pptx
@@ -15,6 +15,8 @@
     <p:sldId id="263" r:id="rId14"/>
     <p:sldId id="264" r:id="rId15"/>
     <p:sldId id="265" r:id="rId16"/>
+    <p:sldId id="266" r:id="rId17"/>
+    <p:sldId id="267" r:id="rId18"/>
   </p:sldIdLst>
   <p:sldSz cx="9144000" cy="6858000" type="screen4x3"/>
   <p:notesSz cx="6858000" cy="9144000"/>
@@ -3359,6 +3361,696 @@
               </a:defRPr>
             </a:pPr>
             <a:r>
+              <a:t>Case Management &amp; Document Downloads</a:t>
+            </a:r>
+          </a:p>
+        </p:txBody>
+      </p:sp>
+      <p:cxnSp>
+        <p:nvCxnSpPr>
+          <p:cNvPr id="5" name="Connector 4"/>
+          <p:cNvCxnSpPr/>
+          <p:nvPr/>
+        </p:nvCxnSpPr>
+        <p:spPr>
+          <a:xfrm>
+            <a:off x="731520" y="1280160"/>
+            <a:ext cx="2468880" cy="0"/>
+          </a:xfrm>
+          <a:prstGeom prst="line">
+            <a:avLst/>
+          </a:prstGeom>
+          <a:ln w="50800">
+            <a:solidFill>
+              <a:srgbClr val="EA3D75"/>
+            </a:solidFill>
+          </a:ln>
+        </p:spPr>
+        <p:style>
+          <a:lnRef idx="2">
+            <a:schemeClr val="accent1"/>
+          </a:lnRef>
+          <a:fillRef idx="0">
+            <a:schemeClr val="accent1"/>
+          </a:fillRef>
+          <a:effectRef idx="1">
+            <a:schemeClr val="accent1"/>
+          </a:effectRef>
+          <a:fontRef idx="minor">
+            <a:schemeClr val="tx1"/>
+          </a:fontRef>
+        </p:style>
+      </p:cxnSp>
+      <p:sp>
+        <p:nvSpPr>
+          <p:cNvPr id="6" name="TextBox 5"/>
+          <p:cNvSpPr txBox="1"/>
+          <p:nvPr/>
+        </p:nvSpPr>
+        <p:spPr>
+          <a:xfrm>
+            <a:off x="731520" y="1600200"/>
+            <a:ext cx="7680960" cy="4800600"/>
+          </a:xfrm>
+          <a:prstGeom prst="rect">
+            <a:avLst/>
+          </a:prstGeom>
+          <a:noFill/>
+        </p:spPr>
+        <p:txBody>
+          <a:bodyPr wrap="square" anchor="t">
+            <a:spAutoFit/>
+          </a:bodyPr>
+          <a:lstStyle/>
+          <a:p>
+            <a:pPr>
+              <a:spcBef>
+                <a:spcPts val="600"/>
+              </a:spcBef>
+              <a:spcAft>
+                <a:spcPts val="600"/>
+              </a:spcAft>
+              <a:defRPr sz="1800">
+                <a:solidFill>
+                  <a:srgbClr val="374151"/>
+                </a:solidFill>
+              </a:defRPr>
+            </a:pPr>
+            <a:r>
+              <a:t>Consolidate related alerts and evidence into formal investigation cases</a:t>
+            </a:r>
+          </a:p>
+          <a:p>
+            <a:pPr>
+              <a:spcBef>
+                <a:spcPts val="600"/>
+              </a:spcBef>
+              <a:spcAft>
+                <a:spcPts val="600"/>
+              </a:spcAft>
+              <a:defRPr sz="1800">
+                <a:solidFill>
+                  <a:srgbClr val="374151"/>
+                </a:solidFill>
+              </a:defRPr>
+            </a:pPr>
+            <a:r>
+              <a:t>Document Generation &amp; Download</a:t>
+            </a:r>
+          </a:p>
+          <a:p>
+            <a:pPr lvl="1">
+              <a:spcBef>
+                <a:spcPts val="600"/>
+              </a:spcBef>
+              <a:spcAft>
+                <a:spcPts val="600"/>
+              </a:spcAft>
+              <a:defRPr sz="1600">
+                <a:solidFill>
+                  <a:srgbClr val="374151"/>
+                </a:solidFill>
+              </a:defRPr>
+            </a:pPr>
+            <a:r>
+              <a:rPr b="1"/>
+              <a:t>Police FIR</a:t>
+            </a:r>
+            <a:r>
+              <a:t> — Download full investigation report with all case details</a:t>
+            </a:r>
+          </a:p>
+          <a:p>
+            <a:pPr lvl="1">
+              <a:spcBef>
+                <a:spcPts val="600"/>
+              </a:spcBef>
+              <a:spcAft>
+                <a:spcPts val="600"/>
+              </a:spcAft>
+              <a:defRPr sz="1600">
+                <a:solidFill>
+                  <a:srgbClr val="374151"/>
+                </a:solidFill>
+              </a:defRPr>
+            </a:pPr>
+            <a:r>
+              <a:rPr b="1"/>
+              <a:t>CTR/SAR Filings</a:t>
+            </a:r>
+            <a:r>
+              <a:t> — Download regulatory reports for archival or reprint</a:t>
+            </a:r>
+          </a:p>
+          <a:p>
+            <a:pPr lvl="1">
+              <a:spcBef>
+                <a:spcPts val="600"/>
+              </a:spcBef>
+              <a:spcAft>
+                <a:spcPts val="600"/>
+              </a:spcAft>
+              <a:defRPr sz="1600">
+                <a:solidFill>
+                  <a:srgbClr val="374151"/>
+                </a:solidFill>
+              </a:defRPr>
+            </a:pPr>
+            <a:r>
+              <a:t>Generate formatted .txt documents suitable for filing and compliance</a:t>
+            </a:r>
+          </a:p>
+          <a:p>
+            <a:pPr>
+              <a:spcBef>
+                <a:spcPts val="600"/>
+              </a:spcBef>
+              <a:spcAft>
+                <a:spcPts val="600"/>
+              </a:spcAft>
+              <a:defRPr sz="1800">
+                <a:solidFill>
+                  <a:srgbClr val="374151"/>
+                </a:solidFill>
+              </a:defRPr>
+            </a:pPr>
+            <a:r>
+              <a:t>Evidence Management: Attach documents, screenshots, transaction exports</a:t>
+            </a:r>
+          </a:p>
+          <a:p>
+            <a:pPr>
+              <a:spcBef>
+                <a:spcPts val="600"/>
+              </a:spcBef>
+              <a:spcAft>
+                <a:spcPts val="600"/>
+              </a:spcAft>
+              <a:defRPr sz="1800">
+                <a:solidFill>
+                  <a:srgbClr val="374151"/>
+                </a:solidFill>
+              </a:defRPr>
+            </a:pPr>
+            <a:r>
+              <a:t>Case Types: Fraud, Cyber Attack, Money Laundering, Operational Risk, Internal Misconduct</a:t>
+            </a:r>
+          </a:p>
+          <a:p>
+            <a:pPr>
+              <a:spcBef>
+                <a:spcPts val="600"/>
+              </a:spcBef>
+              <a:spcAft>
+                <a:spcPts val="600"/>
+              </a:spcAft>
+              <a:defRPr sz="1800">
+                <a:solidFill>
+                  <a:srgbClr val="374151"/>
+                </a:solidFill>
+              </a:defRPr>
+            </a:pPr>
+            <a:r>
+              <a:t>Case Lifecycle: Open → Assigned → Under Investigation → Escalated → Closed</a:t>
+            </a:r>
+          </a:p>
+        </p:txBody>
+      </p:sp>
+    </p:spTree>
+  </p:cSld>
+  <p:clrMapOvr>
+    <a:masterClrMapping/>
+  </p:clrMapOvr>
+</p:sld>
+</file>
+
+<file path=ppt/slides/slide11.xml><?xml version="1.0" encoding="utf-8"?>
+<p:sld xmlns:a="http://schemas.openxmlformats.org/drawingml/2006/main" xmlns:p="http://schemas.openxmlformats.org/presentationml/2006/main" xmlns:r="http://schemas.openxmlformats.org/officeDocument/2006/relationships">
+  <p:cSld>
+    <p:bg>
+      <p:bgPr>
+        <a:solidFill>
+          <a:srgbClr val="FFFFFF"/>
+        </a:solidFill>
+        <a:effectLst/>
+      </p:bgPr>
+    </p:bg>
+    <p:spTree>
+      <p:nvGrpSpPr>
+        <p:cNvPr id="1" name=""/>
+        <p:cNvGrpSpPr/>
+        <p:nvPr/>
+      </p:nvGrpSpPr>
+      <p:grpSpPr/>
+      <p:sp>
+        <p:nvSpPr>
+          <p:cNvPr id="2" name="Rectangle 1"/>
+          <p:cNvSpPr/>
+          <p:nvPr/>
+        </p:nvSpPr>
+        <p:spPr>
+          <a:xfrm>
+            <a:off x="0" y="0"/>
+            <a:ext cx="9144000" cy="73152"/>
+          </a:xfrm>
+          <a:prstGeom prst="rect">
+            <a:avLst/>
+          </a:prstGeom>
+          <a:solidFill>
+            <a:srgbClr val="1F4380"/>
+          </a:solidFill>
+          <a:ln>
+            <a:solidFill>
+              <a:srgbClr val="1F4380"/>
+            </a:solidFill>
+          </a:ln>
+        </p:spPr>
+        <p:style>
+          <a:lnRef idx="1">
+            <a:schemeClr val="accent1"/>
+          </a:lnRef>
+          <a:fillRef idx="3">
+            <a:schemeClr val="accent1"/>
+          </a:fillRef>
+          <a:effectRef idx="2">
+            <a:schemeClr val="accent1"/>
+          </a:effectRef>
+          <a:fontRef idx="minor">
+            <a:schemeClr val="lt1"/>
+          </a:fontRef>
+        </p:style>
+        <p:txBody>
+          <a:bodyPr rtlCol="0" anchor="ctr"/>
+          <a:lstStyle/>
+          <a:p>
+            <a:pPr algn="ctr"/>
+          </a:p>
+        </p:txBody>
+      </p:sp>
+      <p:pic>
+        <p:nvPicPr>
+          <p:cNvPr id="3" name="Picture 2" descr="finsurgelogo.png"/>
+          <p:cNvPicPr>
+            <a:picLocks noChangeAspect="1"/>
+          </p:cNvPicPr>
+          <p:nvPr/>
+        </p:nvPicPr>
+        <p:blipFill>
+          <a:blip r:embed="rId2"/>
+          <a:stretch>
+            <a:fillRect/>
+          </a:stretch>
+        </p:blipFill>
+        <p:spPr>
+          <a:xfrm>
+            <a:off x="8046720" y="274320"/>
+            <a:ext cx="581558" cy="548640"/>
+          </a:xfrm>
+          <a:prstGeom prst="rect">
+            <a:avLst/>
+          </a:prstGeom>
+        </p:spPr>
+      </p:pic>
+      <p:sp>
+        <p:nvSpPr>
+          <p:cNvPr id="4" name="TextBox 3"/>
+          <p:cNvSpPr txBox="1"/>
+          <p:nvPr/>
+        </p:nvSpPr>
+        <p:spPr>
+          <a:xfrm>
+            <a:off x="731520" y="320040"/>
+            <a:ext cx="7498079" cy="868680"/>
+          </a:xfrm>
+          <a:prstGeom prst="rect">
+            <a:avLst/>
+          </a:prstGeom>
+          <a:noFill/>
+        </p:spPr>
+        <p:txBody>
+          <a:bodyPr wrap="square" anchor="ctr">
+            <a:spAutoFit/>
+          </a:bodyPr>
+          <a:lstStyle/>
+          <a:p>
+            <a:pPr>
+              <a:defRPr sz="3800" b="1">
+                <a:solidFill>
+                  <a:srgbClr val="1F4380"/>
+                </a:solidFill>
+              </a:defRPr>
+            </a:pPr>
+            <a:r>
+              <a:t>Regulatory Filing &amp; Real-Time Monitoring</a:t>
+            </a:r>
+          </a:p>
+        </p:txBody>
+      </p:sp>
+      <p:cxnSp>
+        <p:nvCxnSpPr>
+          <p:cNvPr id="5" name="Connector 4"/>
+          <p:cNvCxnSpPr/>
+          <p:nvPr/>
+        </p:nvCxnSpPr>
+        <p:spPr>
+          <a:xfrm>
+            <a:off x="731520" y="1280160"/>
+            <a:ext cx="2468880" cy="0"/>
+          </a:xfrm>
+          <a:prstGeom prst="line">
+            <a:avLst/>
+          </a:prstGeom>
+          <a:ln w="50800">
+            <a:solidFill>
+              <a:srgbClr val="EA3D75"/>
+            </a:solidFill>
+          </a:ln>
+        </p:spPr>
+        <p:style>
+          <a:lnRef idx="2">
+            <a:schemeClr val="accent1"/>
+          </a:lnRef>
+          <a:fillRef idx="0">
+            <a:schemeClr val="accent1"/>
+          </a:fillRef>
+          <a:effectRef idx="1">
+            <a:schemeClr val="accent1"/>
+          </a:effectRef>
+          <a:fontRef idx="minor">
+            <a:schemeClr val="tx1"/>
+          </a:fontRef>
+        </p:style>
+      </p:cxnSp>
+      <p:sp>
+        <p:nvSpPr>
+          <p:cNvPr id="6" name="TextBox 5"/>
+          <p:cNvSpPr txBox="1"/>
+          <p:nvPr/>
+        </p:nvSpPr>
+        <p:spPr>
+          <a:xfrm>
+            <a:off x="731520" y="1600200"/>
+            <a:ext cx="7680960" cy="4800600"/>
+          </a:xfrm>
+          <a:prstGeom prst="rect">
+            <a:avLst/>
+          </a:prstGeom>
+          <a:noFill/>
+        </p:spPr>
+        <p:txBody>
+          <a:bodyPr wrap="square" anchor="t">
+            <a:spAutoFit/>
+          </a:bodyPr>
+          <a:lstStyle/>
+          <a:p>
+            <a:pPr>
+              <a:spcBef>
+                <a:spcPts val="600"/>
+              </a:spcBef>
+              <a:spcAft>
+                <a:spcPts val="600"/>
+              </a:spcAft>
+              <a:defRPr sz="1800">
+                <a:solidFill>
+                  <a:srgbClr val="374151"/>
+                </a:solidFill>
+              </a:defRPr>
+            </a:pPr>
+            <a:r>
+              <a:t>Automated filing workflow with document generation and downloads</a:t>
+            </a:r>
+          </a:p>
+          <a:p>
+            <a:pPr>
+              <a:spcBef>
+                <a:spcPts val="600"/>
+              </a:spcBef>
+              <a:spcAft>
+                <a:spcPts val="600"/>
+              </a:spcAft>
+              <a:defRPr sz="1800">
+                <a:solidFill>
+                  <a:srgbClr val="374151"/>
+                </a:solidFill>
+              </a:defRPr>
+            </a:pPr>
+            <a:r>
+              <a:t>CTR/SAR Filings: Download reports with complete filing details</a:t>
+            </a:r>
+          </a:p>
+          <a:p>
+            <a:pPr>
+              <a:spcBef>
+                <a:spcPts val="600"/>
+              </a:spcBef>
+              <a:spcAft>
+                <a:spcPts val="600"/>
+              </a:spcAft>
+              <a:defRPr sz="1800">
+                <a:solidFill>
+                  <a:srgbClr val="374151"/>
+                </a:solidFill>
+              </a:defRPr>
+            </a:pPr>
+            <a:r>
+              <a:t>FIR Management: File reports with police, track progress, download documents</a:t>
+            </a:r>
+          </a:p>
+          <a:p>
+            <a:pPr>
+              <a:spcBef>
+                <a:spcPts val="600"/>
+              </a:spcBef>
+              <a:spcAft>
+                <a:spcPts val="600"/>
+              </a:spcAft>
+              <a:defRPr sz="1800">
+                <a:solidFill>
+                  <a:srgbClr val="374151"/>
+                </a:solidFill>
+              </a:defRPr>
+            </a:pPr>
+            <a:r>
+              <a:t>Executive visibility into risk management operations</a:t>
+            </a:r>
+          </a:p>
+          <a:p>
+            <a:pPr>
+              <a:spcBef>
+                <a:spcPts val="600"/>
+              </a:spcBef>
+              <a:spcAft>
+                <a:spcPts val="600"/>
+              </a:spcAft>
+              <a:defRPr sz="1800">
+                <a:solidFill>
+                  <a:srgbClr val="374151"/>
+                </a:solidFill>
+              </a:defRPr>
+            </a:pPr>
+            <a:r>
+              <a:t>Key Performance Indicators (Real-Time)</a:t>
+            </a:r>
+          </a:p>
+          <a:p>
+            <a:pPr lvl="1">
+              <a:spcBef>
+                <a:spcPts val="600"/>
+              </a:spcBef>
+              <a:spcAft>
+                <a:spcPts val="600"/>
+              </a:spcAft>
+              <a:defRPr sz="1600">
+                <a:solidFill>
+                  <a:srgbClr val="374151"/>
+                </a:solidFill>
+              </a:defRPr>
+            </a:pPr>
+            <a:r>
+              <a:t>New alerts (24h), Overdue alerts, New cases, Closure rate, SLA compliance %</a:t>
+            </a:r>
+          </a:p>
+          <a:p>
+            <a:pPr>
+              <a:spcBef>
+                <a:spcPts val="600"/>
+              </a:spcBef>
+              <a:spcAft>
+                <a:spcPts val="600"/>
+              </a:spcAft>
+              <a:defRPr sz="1800">
+                <a:solidFill>
+                  <a:srgbClr val="374151"/>
+                </a:solidFill>
+              </a:defRPr>
+            </a:pPr>
+            <a:r>
+              <a:t>Operational Dashboards</a:t>
+            </a:r>
+          </a:p>
+          <a:p>
+            <a:pPr lvl="1">
+              <a:spcBef>
+                <a:spcPts val="600"/>
+              </a:spcBef>
+              <a:spcAft>
+                <a:spcPts val="600"/>
+              </a:spcAft>
+              <a:defRPr sz="1600">
+                <a:solidFill>
+                  <a:srgbClr val="374151"/>
+                </a:solidFill>
+              </a:defRPr>
+            </a:pPr>
+            <a:r>
+              <a:t>Alert heatmap by hour, customer segment, rule category</a:t>
+            </a:r>
+          </a:p>
+          <a:p>
+            <a:pPr lvl="1">
+              <a:spcBef>
+                <a:spcPts val="600"/>
+              </a:spcBef>
+              <a:spcAft>
+                <a:spcPts val="600"/>
+              </a:spcAft>
+              <a:defRPr sz="1600">
+                <a:solidFill>
+                  <a:srgbClr val="374151"/>
+                </a:solidFill>
+              </a:defRPr>
+            </a:pPr>
+            <a:r>
+              <a:t>Team workload and case resolution metrics</a:t>
+            </a:r>
+          </a:p>
+        </p:txBody>
+      </p:sp>
+    </p:spTree>
+  </p:cSld>
+  <p:clrMapOvr>
+    <a:masterClrMapping/>
+  </p:clrMapOvr>
+</p:sld>
+</file>
+
+<file path=ppt/slides/slide12.xml><?xml version="1.0" encoding="utf-8"?>
+<p:sld xmlns:a="http://schemas.openxmlformats.org/drawingml/2006/main" xmlns:p="http://schemas.openxmlformats.org/presentationml/2006/main" xmlns:r="http://schemas.openxmlformats.org/officeDocument/2006/relationships">
+  <p:cSld>
+    <p:bg>
+      <p:bgPr>
+        <a:solidFill>
+          <a:srgbClr val="FFFFFF"/>
+        </a:solidFill>
+        <a:effectLst/>
+      </p:bgPr>
+    </p:bg>
+    <p:spTree>
+      <p:nvGrpSpPr>
+        <p:cNvPr id="1" name=""/>
+        <p:cNvGrpSpPr/>
+        <p:nvPr/>
+      </p:nvGrpSpPr>
+      <p:grpSpPr/>
+      <p:sp>
+        <p:nvSpPr>
+          <p:cNvPr id="2" name="Rectangle 1"/>
+          <p:cNvSpPr/>
+          <p:nvPr/>
+        </p:nvSpPr>
+        <p:spPr>
+          <a:xfrm>
+            <a:off x="0" y="0"/>
+            <a:ext cx="9144000" cy="73152"/>
+          </a:xfrm>
+          <a:prstGeom prst="rect">
+            <a:avLst/>
+          </a:prstGeom>
+          <a:solidFill>
+            <a:srgbClr val="1F4380"/>
+          </a:solidFill>
+          <a:ln>
+            <a:solidFill>
+              <a:srgbClr val="1F4380"/>
+            </a:solidFill>
+          </a:ln>
+        </p:spPr>
+        <p:style>
+          <a:lnRef idx="1">
+            <a:schemeClr val="accent1"/>
+          </a:lnRef>
+          <a:fillRef idx="3">
+            <a:schemeClr val="accent1"/>
+          </a:fillRef>
+          <a:effectRef idx="2">
+            <a:schemeClr val="accent1"/>
+          </a:effectRef>
+          <a:fontRef idx="minor">
+            <a:schemeClr val="lt1"/>
+          </a:fontRef>
+        </p:style>
+        <p:txBody>
+          <a:bodyPr rtlCol="0" anchor="ctr"/>
+          <a:lstStyle/>
+          <a:p>
+            <a:pPr algn="ctr"/>
+          </a:p>
+        </p:txBody>
+      </p:sp>
+      <p:pic>
+        <p:nvPicPr>
+          <p:cNvPr id="3" name="Picture 2" descr="finsurgelogo.png"/>
+          <p:cNvPicPr>
+            <a:picLocks noChangeAspect="1"/>
+          </p:cNvPicPr>
+          <p:nvPr/>
+        </p:nvPicPr>
+        <p:blipFill>
+          <a:blip r:embed="rId2"/>
+          <a:stretch>
+            <a:fillRect/>
+          </a:stretch>
+        </p:blipFill>
+        <p:spPr>
+          <a:xfrm>
+            <a:off x="8046720" y="274320"/>
+            <a:ext cx="581558" cy="548640"/>
+          </a:xfrm>
+          <a:prstGeom prst="rect">
+            <a:avLst/>
+          </a:prstGeom>
+        </p:spPr>
+      </p:pic>
+      <p:sp>
+        <p:nvSpPr>
+          <p:cNvPr id="4" name="TextBox 3"/>
+          <p:cNvSpPr txBox="1"/>
+          <p:nvPr/>
+        </p:nvSpPr>
+        <p:spPr>
+          <a:xfrm>
+            <a:off x="731520" y="320040"/>
+            <a:ext cx="7498079" cy="868680"/>
+          </a:xfrm>
+          <a:prstGeom prst="rect">
+            <a:avLst/>
+          </a:prstGeom>
+          <a:noFill/>
+        </p:spPr>
+        <p:txBody>
+          <a:bodyPr wrap="square" anchor="ctr">
+            <a:spAutoFit/>
+          </a:bodyPr>
+          <a:lstStyle/>
+          <a:p>
+            <a:pPr>
+              <a:defRPr sz="3800" b="1">
+                <a:solidFill>
+                  <a:srgbClr val="1F4380"/>
+                </a:solidFill>
+              </a:defRPr>
+            </a:pPr>
+            <a:r>
               <a:t>Audit Trail, Security &amp; Governance</a:t>
             </a:r>
           </a:p>
@@ -3821,7 +4513,7 @@
               </a:defRPr>
             </a:pPr>
             <a:r>
-              <a:t>92 detection rules organized into 22 detection scenarios covering:</a:t>
+              <a:t>77 detection rules organized into 17 detection scenarios covering:</a:t>
             </a:r>
           </a:p>
           <a:p>
@@ -4409,7 +5101,7 @@
               </a:defRPr>
             </a:pPr>
             <a:r>
-              <a:t>RMA AML/CFT Compliance (Bhutan)</a:t>
+              <a:t>Investigation Copilot — AI-Powered Analysis</a:t>
             </a:r>
           </a:p>
         </p:txBody>
@@ -4485,7 +5177,7 @@
               </a:defRPr>
             </a:pPr>
             <a:r>
-              <a:t>Comprehensive Anti-Money Laundering &amp; Counter-Financing of Terrorism controls</a:t>
+              <a:t>AI-assisted investigation platform accelerating alert analysis and case resolution</a:t>
             </a:r>
           </a:p>
           <a:p>
@@ -4503,7 +5195,7 @@
               </a:defRPr>
             </a:pPr>
             <a:r>
-              <a:t>Customer Due Diligence (CDD) &amp; Enhanced Due Diligence (EDD)</a:t>
+              <a:t>Risk Score Transparency</a:t>
             </a:r>
           </a:p>
           <a:p>
@@ -4521,7 +5213,7 @@
               </a:defRPr>
             </a:pPr>
             <a:r>
-              <a:t>Full KYC verification at account opening with document validation</a:t>
+              <a:t>Hover tooltips show exact risk score formula: Base Alert + Risk Factors + PEP Flag + Severity</a:t>
             </a:r>
           </a:p>
           <a:p>
@@ -4539,7 +5231,29 @@
               </a:defRPr>
             </a:pPr>
             <a:r>
-              <a:t>Automated PEP screening for politically exposed persons</a:t>
+              <a:t>Helps investigators understand why alerts are prioritized and which cases need immediate attention</a:t>
+            </a:r>
+          </a:p>
+          <a:p>
+            <a:pPr>
+              <a:spcBef>
+                <a:spcPts val="600"/>
+              </a:spcBef>
+              <a:spcAft>
+                <a:spcPts val="600"/>
+              </a:spcAft>
+              <a:defRPr sz="1800">
+                <a:solidFill>
+                  <a:srgbClr val="374151"/>
+                </a:solidFill>
+              </a:defRPr>
+            </a:pPr>
+            <a:r>
+              <a:rPr b="1"/>
+              <a:t>Ask the Copilot</a:t>
+            </a:r>
+            <a:r>
+              <a:t> — Conversational Investigation</a:t>
             </a:r>
           </a:p>
           <a:p>
@@ -4557,7 +5271,55 @@
               </a:defRPr>
             </a:pPr>
             <a:r>
-              <a:t>Ultimate Beneficial Owner (UBO) identification and verification</a:t>
+              <a:rPr b="1"/>
+              <a:t>'Why is this customer flagged?'</a:t>
+            </a:r>
+            <a:r>
+              <a:t> — Copilot explains detection pattern and rule triggers</a:t>
+            </a:r>
+          </a:p>
+          <a:p>
+            <a:pPr lvl="1">
+              <a:spcBef>
+                <a:spcPts val="600"/>
+              </a:spcBef>
+              <a:spcAft>
+                <a:spcPts val="600"/>
+              </a:spcAft>
+              <a:defRPr sz="1600">
+                <a:solidFill>
+                  <a:srgbClr val="374151"/>
+                </a:solidFill>
+              </a:defRPr>
+            </a:pPr>
+            <a:r>
+              <a:rPr b="1"/>
+              <a:t>'Show similar cases'</a:t>
+            </a:r>
+            <a:r>
+              <a:t> — Retrieves historical closed cases with matching characteristics</a:t>
+            </a:r>
+          </a:p>
+          <a:p>
+            <a:pPr lvl="1">
+              <a:spcBef>
+                <a:spcPts val="600"/>
+              </a:spcBef>
+              <a:spcAft>
+                <a:spcPts val="600"/>
+              </a:spcAft>
+              <a:defRPr sz="1600">
+                <a:solidFill>
+                  <a:srgbClr val="374151"/>
+                </a:solidFill>
+              </a:defRPr>
+            </a:pPr>
+            <a:r>
+              <a:rPr b="1"/>
+              <a:t>'What are next steps?'</a:t>
+            </a:r>
+            <a:r>
+              <a:t> — Recommends investigation actions based on alert profile</a:t>
             </a:r>
           </a:p>
           <a:p>
@@ -4575,61 +5337,7 @@
               </a:defRPr>
             </a:pPr>
             <a:r>
-              <a:t>Ongoing Transaction Monitoring</a:t>
-            </a:r>
-          </a:p>
-          <a:p>
-            <a:pPr lvl="1">
-              <a:spcBef>
-                <a:spcPts val="600"/>
-              </a:spcBef>
-              <a:spcAft>
-                <a:spcPts val="600"/>
-              </a:spcAft>
-              <a:defRPr sz="1600">
-                <a:solidFill>
-                  <a:srgbClr val="374151"/>
-                </a:solidFill>
-              </a:defRPr>
-            </a:pPr>
-            <a:r>
-              <a:t>Real-time screening of all transactions against risk patterns</a:t>
-            </a:r>
-          </a:p>
-          <a:p>
-            <a:pPr lvl="1">
-              <a:spcBef>
-                <a:spcPts val="600"/>
-              </a:spcBef>
-              <a:spcAft>
-                <a:spcPts val="600"/>
-              </a:spcAft>
-              <a:defRPr sz="1600">
-                <a:solidFill>
-                  <a:srgbClr val="374151"/>
-                </a:solidFill>
-              </a:defRPr>
-            </a:pPr>
-            <a:r>
-              <a:t>Sanctions screening against OFAC, UN, and FATF watchlists</a:t>
-            </a:r>
-          </a:p>
-          <a:p>
-            <a:pPr>
-              <a:spcBef>
-                <a:spcPts val="600"/>
-              </a:spcBef>
-              <a:spcAft>
-                <a:spcPts val="600"/>
-              </a:spcAft>
-              <a:defRPr sz="1800">
-                <a:solidFill>
-                  <a:srgbClr val="374151"/>
-                </a:solidFill>
-              </a:defRPr>
-            </a:pPr>
-            <a:r>
-              <a:t>Suspicious Transaction Reporting (STR) to FIU-Bhutan within 7 days</a:t>
+              <a:t>Context Integration: Previous cases, activity timeline, related alerts, network relationships in one unified view</a:t>
             </a:r>
           </a:p>
         </p:txBody>
@@ -4759,7 +5467,7 @@
               </a:defRPr>
             </a:pPr>
             <a:r>
-              <a:t>RMA Regulatory Reporting &amp; LVTR</a:t>
+              <a:t>Regulatory Document Generation</a:t>
             </a:r>
           </a:p>
         </p:txBody>
@@ -4835,7 +5543,7 @@
               </a:defRPr>
             </a:pPr>
             <a:r>
-              <a:t>Automated filing with RMA and Financial Intelligence Unit - Bhutan</a:t>
+              <a:t>Multi-jurisdictional compliance document automation with format selection</a:t>
             </a:r>
           </a:p>
           <a:p>
@@ -4853,7 +5561,11 @@
               </a:defRPr>
             </a:pPr>
             <a:r>
-              <a:t>Suspicious Transaction Reporting (STR)</a:t>
+              <a:rPr b="1"/>
+              <a:t>CTR/LCTR</a:t>
+            </a:r>
+            <a:r>
+              <a:t> — Cash Transaction Reporting</a:t>
             </a:r>
           </a:p>
           <a:p>
@@ -4871,7 +5583,7 @@
               </a:defRPr>
             </a:pPr>
             <a:r>
-              <a:t>Integrated STR workflow with 7-day filing deadline to FIU-Bhutan</a:t>
+              <a:t>RBI Format: FIU-IND reference, INR 10 Lakh threshold, India compliance</a:t>
             </a:r>
           </a:p>
           <a:p>
@@ -4889,7 +5601,7 @@
               </a:defRPr>
             </a:pPr>
             <a:r>
-              <a:t>Comprehensive case documentation and investigation tracking</a:t>
+              <a:t>RMA Format: FIU-Bhutan reference, Nu. 100,000 threshold, Bhutan AML/CFT Rules 2009</a:t>
             </a:r>
           </a:p>
           <a:p>
@@ -4907,7 +5619,11 @@
               </a:defRPr>
             </a:pPr>
             <a:r>
-              <a:t>Large Value Transaction Reporting (LVTR)</a:t>
+              <a:rPr b="1"/>
+              <a:t>STR/SAR</a:t>
+            </a:r>
+            <a:r>
+              <a:t> — Suspicious Transaction Reporting</a:t>
             </a:r>
           </a:p>
           <a:p>
@@ -4925,7 +5641,7 @@
               </a:defRPr>
             </a:pPr>
             <a:r>
-              <a:t>Track and report transactions exceeding Nu. 100,000 threshold</a:t>
+              <a:t>RBI Format: PMLA-compliant STR with principal officer workflow</a:t>
             </a:r>
           </a:p>
           <a:p>
@@ -4943,7 +5659,7 @@
               </a:defRPr>
             </a:pPr>
             <a:r>
-              <a:t>Full transaction records maintained for 5-year RMA requirement</a:t>
+              <a:t>RMA Format: AML/CFT Rules 2009, Section 11, 7-day filing deadline</a:t>
             </a:r>
           </a:p>
           <a:p>
@@ -4961,7 +5677,11 @@
               </a:defRPr>
             </a:pPr>
             <a:r>
-              <a:t>Annual AML/CFT Compliance Report</a:t>
+              <a:rPr b="1"/>
+              <a:t>LVTR</a:t>
+            </a:r>
+            <a:r>
+              <a:t> — Large Value Transaction Report (RMA Rule 14)</a:t>
             </a:r>
           </a:p>
           <a:p>
@@ -4979,7 +5699,47 @@
               </a:defRPr>
             </a:pPr>
             <a:r>
-              <a:t>Board-level reporting with metrics and incident summary</a:t>
+              <a:t>Track Nu. 100,000+ transactions; 7-day filing window; full 5-year audit trail</a:t>
+            </a:r>
+          </a:p>
+          <a:p>
+            <a:pPr>
+              <a:spcBef>
+                <a:spcPts val="600"/>
+              </a:spcBef>
+              <a:spcAft>
+                <a:spcPts val="600"/>
+              </a:spcAft>
+              <a:defRPr sz="1800">
+                <a:solidFill>
+                  <a:srgbClr val="374151"/>
+                </a:solidFill>
+              </a:defRPr>
+            </a:pPr>
+            <a:r>
+              <a:rPr b="1"/>
+              <a:t>FIR</a:t>
+            </a:r>
+            <a:r>
+              <a:t> — Police First Information Reports</a:t>
+            </a:r>
+          </a:p>
+          <a:p>
+            <a:pPr lvl="1">
+              <a:spcBef>
+                <a:spcPts val="600"/>
+              </a:spcBef>
+              <a:spcAft>
+                <a:spcPts val="600"/>
+              </a:spcAft>
+              <a:defRPr sz="1600">
+                <a:solidFill>
+                  <a:srgbClr val="374151"/>
+                </a:solidFill>
+              </a:defRPr>
+            </a:pPr>
+            <a:r>
+              <a:t>India Police (IPC sections); Bhutan Police (BPC 2004 sections with MLPCA/BICMA references)</a:t>
             </a:r>
           </a:p>
         </p:txBody>
@@ -5109,7 +5869,7 @@
               </a:defRPr>
             </a:pPr>
             <a:r>
-              <a:t>Compliance Scorecard — Live Metrics</a:t>
+              <a:t>RMA AML/CFT Compliance (Bhutan)</a:t>
             </a:r>
           </a:p>
         </p:txBody>
@@ -5185,7 +5945,7 @@
               </a:defRPr>
             </a:pPr>
             <a:r>
-              <a:t>Real-time compliance tracking with auto-calculated scores</a:t>
+              <a:t>Comprehensive Anti-Money Laundering &amp; Counter-Financing of Terrorism controls</a:t>
             </a:r>
           </a:p>
           <a:p>
@@ -5203,7 +5963,7 @@
               </a:defRPr>
             </a:pPr>
             <a:r>
-              <a:t>RBI Scorecard: 16 requirements across 4 sections</a:t>
+              <a:t>Customer Due Diligence (CDD) &amp; Enhanced Due Diligence (EDD)</a:t>
             </a:r>
           </a:p>
           <a:p>
@@ -5221,7 +5981,43 @@
               </a:defRPr>
             </a:pPr>
             <a:r>
-              <a:t>Fraud Risk Management, Data Governance, Reporting, IT Security</a:t>
+              <a:t>Full KYC verification at account opening with document validation</a:t>
+            </a:r>
+          </a:p>
+          <a:p>
+            <a:pPr lvl="1">
+              <a:spcBef>
+                <a:spcPts val="600"/>
+              </a:spcBef>
+              <a:spcAft>
+                <a:spcPts val="600"/>
+              </a:spcAft>
+              <a:defRPr sz="1600">
+                <a:solidFill>
+                  <a:srgbClr val="374151"/>
+                </a:solidFill>
+              </a:defRPr>
+            </a:pPr>
+            <a:r>
+              <a:t>Automated PEP screening for politically exposed persons</a:t>
+            </a:r>
+          </a:p>
+          <a:p>
+            <a:pPr lvl="1">
+              <a:spcBef>
+                <a:spcPts val="600"/>
+              </a:spcBef>
+              <a:spcAft>
+                <a:spcPts val="600"/>
+              </a:spcAft>
+              <a:defRPr sz="1600">
+                <a:solidFill>
+                  <a:srgbClr val="374151"/>
+                </a:solidFill>
+              </a:defRPr>
+            </a:pPr>
+            <a:r>
+              <a:t>Ultimate Beneficial Owner (UBO) identification and verification</a:t>
             </a:r>
           </a:p>
           <a:p>
@@ -5239,7 +6035,7 @@
               </a:defRPr>
             </a:pPr>
             <a:r>
-              <a:t>RMA Scorecard: 14 requirements across 3 sections</a:t>
+              <a:t>Ongoing Transaction Monitoring</a:t>
             </a:r>
           </a:p>
           <a:p>
@@ -5257,7 +6053,25 @@
               </a:defRPr>
             </a:pPr>
             <a:r>
-              <a:t>AML/CFT, Regulatory Reporting, Corporate Governance</a:t>
+              <a:t>Real-time screening of all transactions against risk patterns</a:t>
+            </a:r>
+          </a:p>
+          <a:p>
+            <a:pPr lvl="1">
+              <a:spcBef>
+                <a:spcPts val="600"/>
+              </a:spcBef>
+              <a:spcAft>
+                <a:spcPts val="600"/>
+              </a:spcAft>
+              <a:defRPr sz="1600">
+                <a:solidFill>
+                  <a:srgbClr val="374151"/>
+                </a:solidFill>
+              </a:defRPr>
+            </a:pPr>
+            <a:r>
+              <a:t>Sanctions screening against OFAC, UN, and FATF watchlists</a:t>
             </a:r>
           </a:p>
           <a:p>
@@ -5275,61 +6089,7 @@
               </a:defRPr>
             </a:pPr>
             <a:r>
-              <a:t>Each requirement shows:</a:t>
-            </a:r>
-          </a:p>
-          <a:p>
-            <a:pPr lvl="1">
-              <a:spcBef>
-                <a:spcPts val="600"/>
-              </a:spcBef>
-              <a:spcAft>
-                <a:spcPts val="600"/>
-              </a:spcAft>
-              <a:defRPr sz="1600">
-                <a:solidFill>
-                  <a:srgbClr val="374151"/>
-                </a:solidFill>
-              </a:defRPr>
-            </a:pPr>
-            <a:r>
-              <a:t>Status: Compliant / Partial / At-Risk / Not Implemented</a:t>
-            </a:r>
-          </a:p>
-          <a:p>
-            <a:pPr lvl="1">
-              <a:spcBef>
-                <a:spcPts val="600"/>
-              </a:spcBef>
-              <a:spcAft>
-                <a:spcPts val="600"/>
-              </a:spcAft>
-              <a:defRPr sz="1600">
-                <a:solidFill>
-                  <a:srgbClr val="374151"/>
-                </a:solidFill>
-              </a:defRPr>
-            </a:pPr>
-            <a:r>
-              <a:t>Coverage %: Based on actual system state and metrics</a:t>
-            </a:r>
-          </a:p>
-          <a:p>
-            <a:pPr lvl="1">
-              <a:spcBef>
-                <a:spcPts val="600"/>
-              </a:spcBef>
-              <a:spcAft>
-                <a:spcPts val="600"/>
-              </a:spcAft>
-              <a:defRPr sz="1600">
-                <a:solidFill>
-                  <a:srgbClr val="374151"/>
-                </a:solidFill>
-              </a:defRPr>
-            </a:pPr>
-            <a:r>
-              <a:t>Evidence: Specific data supporting compliance status</a:t>
+              <a:t>Suspicious Transaction Reporting (STR) to FIU-Bhutan within 7 days</a:t>
             </a:r>
           </a:p>
         </p:txBody>
@@ -5459,7 +6219,7 @@
               </a:defRPr>
             </a:pPr>
             <a:r>
-              <a:t>Investigation &amp; Case Management</a:t>
+              <a:t>RMA Regulatory Reporting &amp; LVTR</a:t>
             </a:r>
           </a:p>
         </p:txBody>
@@ -5535,7 +6295,7 @@
               </a:defRPr>
             </a:pPr>
             <a:r>
-              <a:t>Complete alert lifecycle with SLA enforcement and intelligent routing</a:t>
+              <a:t>Automated filing with RMA and Financial Intelligence Unit - Bhutan</a:t>
             </a:r>
           </a:p>
           <a:p>
@@ -5553,7 +6313,43 @@
               </a:defRPr>
             </a:pPr>
             <a:r>
-              <a:t>Alert States: New → Assigned → Under Review → Escalated → Closed</a:t>
+              <a:t>Suspicious Transaction Reporting (STR)</a:t>
+            </a:r>
+          </a:p>
+          <a:p>
+            <a:pPr lvl="1">
+              <a:spcBef>
+                <a:spcPts val="600"/>
+              </a:spcBef>
+              <a:spcAft>
+                <a:spcPts val="600"/>
+              </a:spcAft>
+              <a:defRPr sz="1600">
+                <a:solidFill>
+                  <a:srgbClr val="374151"/>
+                </a:solidFill>
+              </a:defRPr>
+            </a:pPr>
+            <a:r>
+              <a:t>Integrated STR workflow with 7-day filing deadline to FIU-Bhutan</a:t>
+            </a:r>
+          </a:p>
+          <a:p>
+            <a:pPr lvl="1">
+              <a:spcBef>
+                <a:spcPts val="600"/>
+              </a:spcBef>
+              <a:spcAft>
+                <a:spcPts val="600"/>
+              </a:spcAft>
+              <a:defRPr sz="1600">
+                <a:solidFill>
+                  <a:srgbClr val="374151"/>
+                </a:solidFill>
+              </a:defRPr>
+            </a:pPr>
+            <a:r>
+              <a:t>Comprehensive case documentation and investigation tracking</a:t>
             </a:r>
           </a:p>
           <a:p>
@@ -5571,7 +6367,43 @@
               </a:defRPr>
             </a:pPr>
             <a:r>
-              <a:t>Severity-Based SLAs: Critical (4h), High (24h), Medium (72h), Low (168h)</a:t>
+              <a:t>Large Value Transaction Reporting (LVTR)</a:t>
+            </a:r>
+          </a:p>
+          <a:p>
+            <a:pPr lvl="1">
+              <a:spcBef>
+                <a:spcPts val="600"/>
+              </a:spcBef>
+              <a:spcAft>
+                <a:spcPts val="600"/>
+              </a:spcAft>
+              <a:defRPr sz="1600">
+                <a:solidFill>
+                  <a:srgbClr val="374151"/>
+                </a:solidFill>
+              </a:defRPr>
+            </a:pPr>
+            <a:r>
+              <a:t>Track and report transactions exceeding Nu. 100,000 threshold</a:t>
+            </a:r>
+          </a:p>
+          <a:p>
+            <a:pPr lvl="1">
+              <a:spcBef>
+                <a:spcPts val="600"/>
+              </a:spcBef>
+              <a:spcAft>
+                <a:spcPts val="600"/>
+              </a:spcAft>
+              <a:defRPr sz="1600">
+                <a:solidFill>
+                  <a:srgbClr val="374151"/>
+                </a:solidFill>
+              </a:defRPr>
+            </a:pPr>
+            <a:r>
+              <a:t>Full transaction records maintained for 5-year RMA requirement</a:t>
             </a:r>
           </a:p>
           <a:p>
@@ -5589,25 +6421,7 @@
               </a:defRPr>
             </a:pPr>
             <a:r>
-              <a:t>Intelligent Auto-Assignment: Routes alerts to available analysts by skill, workload</a:t>
-            </a:r>
-          </a:p>
-          <a:p>
-            <a:pPr>
-              <a:spcBef>
-                <a:spcPts val="600"/>
-              </a:spcBef>
-              <a:spcAft>
-                <a:spcPts val="600"/>
-              </a:spcAft>
-              <a:defRPr sz="1800">
-                <a:solidFill>
-                  <a:srgbClr val="374151"/>
-                </a:solidFill>
-              </a:defRPr>
-            </a:pPr>
-            <a:r>
-              <a:t>Investigation Features</a:t>
+              <a:t>Annual AML/CFT Compliance Report</a:t>
             </a:r>
           </a:p>
           <a:p>
@@ -5625,43 +6439,7 @@
               </a:defRPr>
             </a:pPr>
             <a:r>
-              <a:t>Add detailed notes, attach evidence documents, link related cases</a:t>
-            </a:r>
-          </a:p>
-          <a:p>
-            <a:pPr lvl="1">
-              <a:spcBef>
-                <a:spcPts val="600"/>
-              </a:spcBef>
-              <a:spcAft>
-                <a:spcPts val="600"/>
-              </a:spcAft>
-              <a:defRPr sz="1600">
-                <a:solidFill>
-                  <a:srgbClr val="374151"/>
-                </a:solidFill>
-              </a:defRPr>
-            </a:pPr>
-            <a:r>
-              <a:t>Bulk actions: Close false positives, escalate groups, reassign batches</a:t>
-            </a:r>
-          </a:p>
-          <a:p>
-            <a:pPr>
-              <a:spcBef>
-                <a:spcPts val="600"/>
-              </a:spcBef>
-              <a:spcAft>
-                <a:spcPts val="600"/>
-              </a:spcAft>
-              <a:defRPr sz="1800">
-                <a:solidFill>
-                  <a:srgbClr val="374151"/>
-                </a:solidFill>
-              </a:defRPr>
-            </a:pPr>
-            <a:r>
-              <a:t>Dashboard Analytics: New alerts trending, SLA compliance %, closure patterns</a:t>
+              <a:t>Board-level reporting with metrics and incident summary</a:t>
             </a:r>
           </a:p>
         </p:txBody>
@@ -5791,7 +6569,7 @@
               </a:defRPr>
             </a:pPr>
             <a:r>
-              <a:t>Case Management &amp; Document Downloads</a:t>
+              <a:t>Compliance Scorecard — Live Metrics</a:t>
             </a:r>
           </a:p>
         </p:txBody>
@@ -5867,7 +6645,7 @@
               </a:defRPr>
             </a:pPr>
             <a:r>
-              <a:t>Consolidate related alerts and evidence into formal investigation cases</a:t>
+              <a:t>Real-time compliance tracking with auto-calculated scores</a:t>
             </a:r>
           </a:p>
           <a:p>
@@ -5885,7 +6663,7 @@
               </a:defRPr>
             </a:pPr>
             <a:r>
-              <a:t>Document Generation &amp; Download</a:t>
+              <a:t>RBI Scorecard: 16 requirements across 4 sections</a:t>
             </a:r>
           </a:p>
           <a:p>
@@ -5903,11 +6681,25 @@
               </a:defRPr>
             </a:pPr>
             <a:r>
-              <a:rPr b="1"/>
-              <a:t>Police FIR</a:t>
-            </a:r>
-            <a:r>
-              <a:t> — Download full investigation report with all case details</a:t>
+              <a:t>Fraud Risk Management, Data Governance, Reporting, IT Security</a:t>
+            </a:r>
+          </a:p>
+          <a:p>
+            <a:pPr>
+              <a:spcBef>
+                <a:spcPts val="600"/>
+              </a:spcBef>
+              <a:spcAft>
+                <a:spcPts val="600"/>
+              </a:spcAft>
+              <a:defRPr sz="1800">
+                <a:solidFill>
+                  <a:srgbClr val="374151"/>
+                </a:solidFill>
+              </a:defRPr>
+            </a:pPr>
+            <a:r>
+              <a:t>RMA Scorecard: 14 requirements across 3 sections</a:t>
             </a:r>
           </a:p>
           <a:p>
@@ -5925,11 +6717,25 @@
               </a:defRPr>
             </a:pPr>
             <a:r>
-              <a:rPr b="1"/>
-              <a:t>CTR/SAR Filings</a:t>
-            </a:r>
-            <a:r>
-              <a:t> — Download regulatory reports for archival or reprint</a:t>
+              <a:t>AML/CFT, Regulatory Reporting, Corporate Governance</a:t>
+            </a:r>
+          </a:p>
+          <a:p>
+            <a:pPr>
+              <a:spcBef>
+                <a:spcPts val="600"/>
+              </a:spcBef>
+              <a:spcAft>
+                <a:spcPts val="600"/>
+              </a:spcAft>
+              <a:defRPr sz="1800">
+                <a:solidFill>
+                  <a:srgbClr val="374151"/>
+                </a:solidFill>
+              </a:defRPr>
+            </a:pPr>
+            <a:r>
+              <a:t>Each requirement shows:</a:t>
             </a:r>
           </a:p>
           <a:p>
@@ -5947,61 +6753,43 @@
               </a:defRPr>
             </a:pPr>
             <a:r>
-              <a:t>Generate formatted .txt documents suitable for filing and compliance</a:t>
-            </a:r>
-          </a:p>
-          <a:p>
-            <a:pPr>
-              <a:spcBef>
-                <a:spcPts val="600"/>
-              </a:spcBef>
-              <a:spcAft>
-                <a:spcPts val="600"/>
-              </a:spcAft>
-              <a:defRPr sz="1800">
-                <a:solidFill>
-                  <a:srgbClr val="374151"/>
-                </a:solidFill>
-              </a:defRPr>
-            </a:pPr>
-            <a:r>
-              <a:t>Evidence Management: Attach documents, screenshots, transaction exports</a:t>
-            </a:r>
-          </a:p>
-          <a:p>
-            <a:pPr>
-              <a:spcBef>
-                <a:spcPts val="600"/>
-              </a:spcBef>
-              <a:spcAft>
-                <a:spcPts val="600"/>
-              </a:spcAft>
-              <a:defRPr sz="1800">
-                <a:solidFill>
-                  <a:srgbClr val="374151"/>
-                </a:solidFill>
-              </a:defRPr>
-            </a:pPr>
-            <a:r>
-              <a:t>Case Types: Fraud, Cyber Attack, Money Laundering, Operational Risk, Internal Misconduct</a:t>
-            </a:r>
-          </a:p>
-          <a:p>
-            <a:pPr>
-              <a:spcBef>
-                <a:spcPts val="600"/>
-              </a:spcBef>
-              <a:spcAft>
-                <a:spcPts val="600"/>
-              </a:spcAft>
-              <a:defRPr sz="1800">
-                <a:solidFill>
-                  <a:srgbClr val="374151"/>
-                </a:solidFill>
-              </a:defRPr>
-            </a:pPr>
-            <a:r>
-              <a:t>Case Lifecycle: Open → Assigned → Under Investigation → Escalated → Closed</a:t>
+              <a:t>Status: Compliant / Partial / At-Risk / Not Implemented</a:t>
+            </a:r>
+          </a:p>
+          <a:p>
+            <a:pPr lvl="1">
+              <a:spcBef>
+                <a:spcPts val="600"/>
+              </a:spcBef>
+              <a:spcAft>
+                <a:spcPts val="600"/>
+              </a:spcAft>
+              <a:defRPr sz="1600">
+                <a:solidFill>
+                  <a:srgbClr val="374151"/>
+                </a:solidFill>
+              </a:defRPr>
+            </a:pPr>
+            <a:r>
+              <a:t>Coverage %: Based on actual system state and metrics</a:t>
+            </a:r>
+          </a:p>
+          <a:p>
+            <a:pPr lvl="1">
+              <a:spcBef>
+                <a:spcPts val="600"/>
+              </a:spcBef>
+              <a:spcAft>
+                <a:spcPts val="600"/>
+              </a:spcAft>
+              <a:defRPr sz="1600">
+                <a:solidFill>
+                  <a:srgbClr val="374151"/>
+                </a:solidFill>
+              </a:defRPr>
+            </a:pPr>
+            <a:r>
+              <a:t>Evidence: Specific data supporting compliance status</a:t>
             </a:r>
           </a:p>
         </p:txBody>
@@ -6131,7 +6919,7 @@
               </a:defRPr>
             </a:pPr>
             <a:r>
-              <a:t>Regulatory Filing &amp; Real-Time Monitoring</a:t>
+              <a:t>Investigation &amp; Case Management</a:t>
             </a:r>
           </a:p>
         </p:txBody>
@@ -6207,7 +6995,7 @@
               </a:defRPr>
             </a:pPr>
             <a:r>
-              <a:t>Automated filing workflow with document generation and downloads</a:t>
+              <a:t>Complete alert lifecycle with SLA enforcement and intelligent routing</a:t>
             </a:r>
           </a:p>
           <a:p>
@@ -6225,7 +7013,7 @@
               </a:defRPr>
             </a:pPr>
             <a:r>
-              <a:t>CTR/SAR Filings: Download reports with complete filing details</a:t>
+              <a:t>Alert States: New → Assigned → Under Review → Escalated → Closed</a:t>
             </a:r>
           </a:p>
           <a:p>
@@ -6243,7 +7031,7 @@
               </a:defRPr>
             </a:pPr>
             <a:r>
-              <a:t>FIR Management: File reports with police, track progress, download documents</a:t>
+              <a:t>Severity-Based SLAs: Critical (4h), High (24h), Medium (72h), Low (168h)</a:t>
             </a:r>
           </a:p>
           <a:p>
@@ -6261,7 +7049,7 @@
               </a:defRPr>
             </a:pPr>
             <a:r>
-              <a:t>Executive visibility into risk management operations</a:t>
+              <a:t>Intelligent Auto-Assignment: Routes alerts to available analysts by skill, workload</a:t>
             </a:r>
           </a:p>
           <a:p>
@@ -6279,7 +7067,7 @@
               </a:defRPr>
             </a:pPr>
             <a:r>
-              <a:t>Key Performance Indicators (Real-Time)</a:t>
+              <a:t>Investigation Features</a:t>
             </a:r>
           </a:p>
           <a:p>
@@ -6297,7 +7085,25 @@
               </a:defRPr>
             </a:pPr>
             <a:r>
-              <a:t>New alerts (24h), Overdue alerts, New cases, Closure rate, SLA compliance %</a:t>
+              <a:t>Add detailed notes, attach evidence documents, link related cases</a:t>
+            </a:r>
+          </a:p>
+          <a:p>
+            <a:pPr lvl="1">
+              <a:spcBef>
+                <a:spcPts val="600"/>
+              </a:spcBef>
+              <a:spcAft>
+                <a:spcPts val="600"/>
+              </a:spcAft>
+              <a:defRPr sz="1600">
+                <a:solidFill>
+                  <a:srgbClr val="374151"/>
+                </a:solidFill>
+              </a:defRPr>
+            </a:pPr>
+            <a:r>
+              <a:t>Bulk actions: Close false positives, escalate groups, reassign batches</a:t>
             </a:r>
           </a:p>
           <a:p>
@@ -6315,43 +7121,7 @@
               </a:defRPr>
             </a:pPr>
             <a:r>
-              <a:t>Operational Dashboards</a:t>
-            </a:r>
-          </a:p>
-          <a:p>
-            <a:pPr lvl="1">
-              <a:spcBef>
-                <a:spcPts val="600"/>
-              </a:spcBef>
-              <a:spcAft>
-                <a:spcPts val="600"/>
-              </a:spcAft>
-              <a:defRPr sz="1600">
-                <a:solidFill>
-                  <a:srgbClr val="374151"/>
-                </a:solidFill>
-              </a:defRPr>
-            </a:pPr>
-            <a:r>
-              <a:t>Alert heatmap by hour, customer segment, rule category</a:t>
-            </a:r>
-          </a:p>
-          <a:p>
-            <a:pPr lvl="1">
-              <a:spcBef>
-                <a:spcPts val="600"/>
-              </a:spcBef>
-              <a:spcAft>
-                <a:spcPts val="600"/>
-              </a:spcAft>
-              <a:defRPr sz="1600">
-                <a:solidFill>
-                  <a:srgbClr val="374151"/>
-                </a:solidFill>
-              </a:defRPr>
-            </a:pPr>
-            <a:r>
-              <a:t>Team workload and case resolution metrics</a:t>
+              <a:t>Dashboard Analytics: New alerts trending, SLA compliance %, closure patterns</a:t>
             </a:r>
           </a:p>
         </p:txBody>

</xml_diff>